<commit_message>
Fix CORS for 127.0.0.1 origin, remove personal phone number from public materials
Backend only allowed the localhost:3000 origin, so the app silently
failed to authenticate when accessed via 127.0.0.1:3000. Also drops the
hardcoded phone number from the UI, docs, and generated slides/PDF
before public submission.

Co-Authored-By: Claude Sonnet 5 <noreply@anthropic.com>
Claude-Session: https://claude.ai/code/session_015tfN2coiTUnhXLiAhXEsq4
</commit_message>
<xml_diff>
--- a/CivicLens-Hackathon-Presentation.pptx
+++ b/CivicLens-Hackathon-Presentation.pptx
@@ -4343,41 +4343,6 @@
       <p:sp>
         <p:nvSpPr>
           <p:cNvPr id="6" name="TextBox 5"/>
-          <p:cNvSpPr txBox="1"/>
-          <p:nvPr/>
-        </p:nvSpPr>
-        <p:spPr>
-          <a:xfrm>
-            <a:off x="914400" y="5029200"/>
-            <a:ext cx="10058400" cy="457200"/>
-          </a:xfrm>
-          <a:prstGeom prst="rect">
-            <a:avLst/>
-          </a:prstGeom>
-          <a:noFill/>
-        </p:spPr>
-        <p:txBody>
-          <a:bodyPr wrap="square">
-            <a:spAutoFit/>
-          </a:bodyPr>
-          <a:lstStyle/>
-          <a:p>
-            <a:pPr algn="ctr">
-              <a:defRPr sz="1600" b="0">
-                <a:solidFill>
-                  <a:srgbClr val="94A3B8"/>
-                </a:solidFill>
-              </a:defRPr>
-            </a:pPr>
-            <a:r>
-              <a:t>0317 750 5992</a:t>
-            </a:r>
-          </a:p>
-        </p:txBody>
-      </p:sp>
-      <p:sp>
-        <p:nvSpPr>
-          <p:cNvPr id="7" name="TextBox 6"/>
           <p:cNvSpPr txBox="1"/>
           <p:nvPr/>
         </p:nvSpPr>

</xml_diff>